<commit_message>
MAJ PPT synthèse : v1.1.0 (jsd, blur_effect, renommages tenengrad_otsu/brenner_vertical)
</commit_message>
<xml_diff>
--- a/resources/eoqual-metrics_synthese.pptx
+++ b/resources/eoqual-metrics_synthese.pptx
@@ -3344,7 +3344,7 @@
                 </a:solidFill>
                 <a:latin typeface="Calibri"/>
               </a:rPr>
-              <a:t>0</a:t>
+              <a:t>1</a:t>
             </a:r>
             <a:r>
               <a:rPr sz="1200" b="0" i="0" dirty="0">
@@ -4626,7 +4626,7 @@
                 </a:solidFill>
                 <a:latin typeface="Consolas"/>
               </a:rPr>
-              <a:t>ncc · nmi · scc · uqi</a:t>
+              <a:t>ncc · nmi · scc · uqi · jsd</a:t>
             </a:r>
           </a:p>
         </p:txBody>
@@ -6211,7 +6211,7 @@
                 </a:solidFill>
                 <a:latin typeface="Consolas"/>
               </a:rPr>
-              <a:t>tenengrad · laplacian · sobel</a:t>
+              <a:t>tenengrad_otsu · laplacian · sobel</a:t>
             </a:r>
           </a:p>
         </p:txBody>
@@ -6727,7 +6727,7 @@
                 </a:solidFill>
                 <a:latin typeface="Consolas"/>
               </a:rPr>
-              <a:t>s3 · mtf · cpbd</a:t>
+              <a:t>s3 · mtf · cpbd · blur_effect</a:t>
             </a:r>
           </a:p>
         </p:txBody>
@@ -6766,7 +6766,7 @@
                 </a:solidFill>
                 <a:latin typeface="Calibri"/>
               </a:rPr>
-              <a:t>Contenu fréquentiel (s3, mtf) et détection de flou (cpbd).</a:t>
+              <a:t>Contenu fréquentiel (s3, mtf) et détection de flou (cpbd, blur_effect).</a:t>
             </a:r>
           </a:p>
         </p:txBody>
@@ -6985,7 +6985,7 @@
                 </a:solidFill>
                 <a:latin typeface="Consolas"/>
               </a:rPr>
-              <a:t>brenner · fft · antonel · blur_kernel · wavelet · aem · sasbem</a:t>
+              <a:t>brenner_vertical · fft · antonel · blur_kernel · wavelet · aem · sasbem</a:t>
             </a:r>
           </a:p>
         </p:txBody>
@@ -7821,7 +7821,7 @@
                 </a:solidFill>
                 <a:latin typeface="Consolas"/>
               </a:rPr>
-              <a:t>tenengrad</a:t>
+              <a:t>tenengrad_otsu</a:t>
             </a:r>
             <a:r>
               <a:rPr sz="1150" b="0" i="0" dirty="0">
@@ -8994,7 +8994,7 @@
                 </a:solidFill>
                 <a:latin typeface="Calibri"/>
               </a:rPr>
-              <a:t>34</a:t>
+              <a:t>35</a:t>
             </a:r>
           </a:p>
         </p:txBody>
@@ -9270,7 +9270,7 @@
                 </a:solidFill>
                 <a:latin typeface="Calibri"/>
               </a:rPr>
-              <a:t>16 algos (5 familles)</a:t>
+              <a:t>17 algos (5 familles)</a:t>
             </a:r>
           </a:p>
         </p:txBody>
@@ -9634,7 +9634,7 @@
                 </a:solidFill>
                 <a:latin typeface="Calibri"/>
               </a:rPr>
-              <a:t>(brenner…sasbem)</a:t>
+              <a:t>(brenner_vertical…sasbem)</a:t>
             </a:r>
           </a:p>
         </p:txBody>

</xml_diff>